<commit_message>
small update in powerpoint
</commit_message>
<xml_diff>
--- a/phase1_presentation_finalversion.pptx
+++ b/phase1_presentation_finalversion.pptx
@@ -1362,6 +1362,13 @@
             <a:prstDash val="solid"/>
           </a:ln>
         </p:spPr>
+        <p:txBody>
+          <a:bodyPr/>
+          <a:lstStyle/>
+          <a:p>
+            <a:endParaRPr lang="LID4096"/>
+          </a:p>
+        </p:txBody>
       </p:sp>
       <p:sp>
         <p:nvSpPr>
@@ -1577,6 +1584,13 @@
             <a:prstDash val="solid"/>
           </a:ln>
         </p:spPr>
+        <p:txBody>
+          <a:bodyPr/>
+          <a:lstStyle/>
+          <a:p>
+            <a:endParaRPr lang="LID4096"/>
+          </a:p>
+        </p:txBody>
       </p:sp>
       <p:sp>
         <p:nvSpPr>
@@ -1680,6 +1694,13 @@
             <a:prstDash val="solid"/>
           </a:ln>
         </p:spPr>
+        <p:txBody>
+          <a:bodyPr/>
+          <a:lstStyle/>
+          <a:p>
+            <a:endParaRPr lang="LID4096"/>
+          </a:p>
+        </p:txBody>
       </p:sp>
       <p:sp>
         <p:nvSpPr>
@@ -1783,6 +1804,13 @@
             <a:prstDash val="solid"/>
           </a:ln>
         </p:spPr>
+        <p:txBody>
+          <a:bodyPr/>
+          <a:lstStyle/>
+          <a:p>
+            <a:endParaRPr lang="LID4096"/>
+          </a:p>
+        </p:txBody>
       </p:sp>
       <p:sp>
         <p:nvSpPr>
@@ -1886,6 +1914,13 @@
             <a:prstDash val="solid"/>
           </a:ln>
         </p:spPr>
+        <p:txBody>
+          <a:bodyPr/>
+          <a:lstStyle/>
+          <a:p>
+            <a:endParaRPr lang="LID4096"/>
+          </a:p>
+        </p:txBody>
       </p:sp>
       <p:sp>
         <p:nvSpPr>
@@ -2052,6 +2087,13 @@
             <a:prstDash val="solid"/>
           </a:ln>
         </p:spPr>
+        <p:txBody>
+          <a:bodyPr/>
+          <a:lstStyle/>
+          <a:p>
+            <a:endParaRPr lang="LID4096"/>
+          </a:p>
+        </p:txBody>
       </p:sp>
       <p:sp>
         <p:nvSpPr>
@@ -2077,6 +2119,13 @@
             <a:prstDash val="solid"/>
           </a:ln>
         </p:spPr>
+        <p:txBody>
+          <a:bodyPr/>
+          <a:lstStyle/>
+          <a:p>
+            <a:endParaRPr lang="LID4096"/>
+          </a:p>
+        </p:txBody>
       </p:sp>
       <p:sp>
         <p:nvSpPr>
@@ -2187,6 +2236,13 @@
             </a:outerShdw>
           </a:effectLst>
         </p:spPr>
+        <p:txBody>
+          <a:bodyPr/>
+          <a:lstStyle/>
+          <a:p>
+            <a:endParaRPr lang="LID4096"/>
+          </a:p>
+        </p:txBody>
       </p:sp>
       <p:sp>
         <p:nvSpPr>
@@ -2212,6 +2268,13 @@
             <a:prstDash val="solid"/>
           </a:ln>
         </p:spPr>
+        <p:txBody>
+          <a:bodyPr/>
+          <a:lstStyle/>
+          <a:p>
+            <a:endParaRPr lang="LID4096"/>
+          </a:p>
+        </p:txBody>
       </p:sp>
       <p:sp>
         <p:nvSpPr>
@@ -2378,6 +2441,13 @@
             <a:prstDash val="solid"/>
           </a:ln>
         </p:spPr>
+        <p:txBody>
+          <a:bodyPr/>
+          <a:lstStyle/>
+          <a:p>
+            <a:endParaRPr lang="LID4096"/>
+          </a:p>
+        </p:txBody>
       </p:sp>
       <p:sp>
         <p:nvSpPr>
@@ -2410,6 +2480,13 @@
             </a:outerShdw>
           </a:effectLst>
         </p:spPr>
+        <p:txBody>
+          <a:bodyPr/>
+          <a:lstStyle/>
+          <a:p>
+            <a:endParaRPr lang="LID4096"/>
+          </a:p>
+        </p:txBody>
       </p:sp>
       <p:sp>
         <p:nvSpPr>
@@ -2435,6 +2512,13 @@
             <a:prstDash val="solid"/>
           </a:ln>
         </p:spPr>
+        <p:txBody>
+          <a:bodyPr/>
+          <a:lstStyle/>
+          <a:p>
+            <a:endParaRPr lang="LID4096"/>
+          </a:p>
+        </p:txBody>
       </p:sp>
       <p:sp>
         <p:nvSpPr>
@@ -2601,6 +2685,13 @@
             <a:prstDash val="solid"/>
           </a:ln>
         </p:spPr>
+        <p:txBody>
+          <a:bodyPr/>
+          <a:lstStyle/>
+          <a:p>
+            <a:endParaRPr lang="LID4096"/>
+          </a:p>
+        </p:txBody>
       </p:sp>
       <p:sp>
         <p:nvSpPr>
@@ -2633,6 +2724,13 @@
             </a:outerShdw>
           </a:effectLst>
         </p:spPr>
+        <p:txBody>
+          <a:bodyPr/>
+          <a:lstStyle/>
+          <a:p>
+            <a:endParaRPr lang="LID4096"/>
+          </a:p>
+        </p:txBody>
       </p:sp>
       <p:sp>
         <p:nvSpPr>
@@ -2658,6 +2756,13 @@
             <a:prstDash val="solid"/>
           </a:ln>
         </p:spPr>
+        <p:txBody>
+          <a:bodyPr/>
+          <a:lstStyle/>
+          <a:p>
+            <a:endParaRPr lang="LID4096"/>
+          </a:p>
+        </p:txBody>
       </p:sp>
       <p:sp>
         <p:nvSpPr>
@@ -2824,6 +2929,13 @@
             <a:prstDash val="solid"/>
           </a:ln>
         </p:spPr>
+        <p:txBody>
+          <a:bodyPr/>
+          <a:lstStyle/>
+          <a:p>
+            <a:endParaRPr lang="LID4096"/>
+          </a:p>
+        </p:txBody>
       </p:sp>
       <p:sp>
         <p:nvSpPr>
@@ -2856,6 +2968,13 @@
             </a:outerShdw>
           </a:effectLst>
         </p:spPr>
+        <p:txBody>
+          <a:bodyPr/>
+          <a:lstStyle/>
+          <a:p>
+            <a:endParaRPr lang="LID4096"/>
+          </a:p>
+        </p:txBody>
       </p:sp>
       <p:sp>
         <p:nvSpPr>
@@ -2881,6 +3000,13 @@
             <a:prstDash val="solid"/>
           </a:ln>
         </p:spPr>
+        <p:txBody>
+          <a:bodyPr/>
+          <a:lstStyle/>
+          <a:p>
+            <a:endParaRPr lang="LID4096"/>
+          </a:p>
+        </p:txBody>
       </p:sp>
       <p:sp>
         <p:nvSpPr>
@@ -3186,6 +3312,13 @@
             <a:prstDash val="solid"/>
           </a:ln>
         </p:spPr>
+        <p:txBody>
+          <a:bodyPr/>
+          <a:lstStyle/>
+          <a:p>
+            <a:endParaRPr lang="LID4096"/>
+          </a:p>
+        </p:txBody>
       </p:sp>
       <p:sp>
         <p:nvSpPr>
@@ -5026,6 +5159,13 @@
             <a:prstDash val="solid"/>
           </a:ln>
         </p:spPr>
+        <p:txBody>
+          <a:bodyPr/>
+          <a:lstStyle/>
+          <a:p>
+            <a:endParaRPr lang="LID4096"/>
+          </a:p>
+        </p:txBody>
       </p:sp>
       <p:sp>
         <p:nvSpPr>
@@ -5051,6 +5191,13 @@
             <a:prstDash val="solid"/>
           </a:ln>
         </p:spPr>
+        <p:txBody>
+          <a:bodyPr/>
+          <a:lstStyle/>
+          <a:p>
+            <a:endParaRPr lang="LID4096"/>
+          </a:p>
+        </p:txBody>
       </p:sp>
       <p:sp>
         <p:nvSpPr>
@@ -5171,6 +5318,13 @@
             <a:prstDash val="solid"/>
           </a:ln>
         </p:spPr>
+        <p:txBody>
+          <a:bodyPr/>
+          <a:lstStyle/>
+          <a:p>
+            <a:endParaRPr lang="LID4096"/>
+          </a:p>
+        </p:txBody>
       </p:sp>
       <p:sp>
         <p:nvSpPr>
@@ -5196,6 +5350,13 @@
             <a:prstDash val="solid"/>
           </a:ln>
         </p:spPr>
+        <p:txBody>
+          <a:bodyPr/>
+          <a:lstStyle/>
+          <a:p>
+            <a:endParaRPr lang="LID4096"/>
+          </a:p>
+        </p:txBody>
       </p:sp>
       <p:sp>
         <p:nvSpPr>
@@ -5316,6 +5477,13 @@
             <a:prstDash val="solid"/>
           </a:ln>
         </p:spPr>
+        <p:txBody>
+          <a:bodyPr/>
+          <a:lstStyle/>
+          <a:p>
+            <a:endParaRPr lang="LID4096"/>
+          </a:p>
+        </p:txBody>
       </p:sp>
       <p:sp>
         <p:nvSpPr>
@@ -5341,6 +5509,13 @@
             <a:prstDash val="solid"/>
           </a:ln>
         </p:spPr>
+        <p:txBody>
+          <a:bodyPr/>
+          <a:lstStyle/>
+          <a:p>
+            <a:endParaRPr lang="LID4096"/>
+          </a:p>
+        </p:txBody>
       </p:sp>
       <p:sp>
         <p:nvSpPr>
@@ -5557,6 +5732,13 @@
             <a:prstDash val="solid"/>
           </a:ln>
         </p:spPr>
+        <p:txBody>
+          <a:bodyPr/>
+          <a:lstStyle/>
+          <a:p>
+            <a:endParaRPr lang="LID4096"/>
+          </a:p>
+        </p:txBody>
       </p:sp>
       <p:sp>
         <p:nvSpPr>
@@ -5667,6 +5849,13 @@
             </a:outerShdw>
           </a:effectLst>
         </p:spPr>
+        <p:txBody>
+          <a:bodyPr/>
+          <a:lstStyle/>
+          <a:p>
+            <a:endParaRPr lang="LID4096"/>
+          </a:p>
+        </p:txBody>
       </p:sp>
       <p:sp>
         <p:nvSpPr>
@@ -5794,6 +5983,13 @@
             </a:outerShdw>
           </a:effectLst>
         </p:spPr>
+        <p:txBody>
+          <a:bodyPr/>
+          <a:lstStyle/>
+          <a:p>
+            <a:endParaRPr lang="LID4096"/>
+          </a:p>
+        </p:txBody>
       </p:sp>
       <p:sp>
         <p:nvSpPr>
@@ -5921,6 +6117,13 @@
             </a:outerShdw>
           </a:effectLst>
         </p:spPr>
+        <p:txBody>
+          <a:bodyPr/>
+          <a:lstStyle/>
+          <a:p>
+            <a:endParaRPr lang="LID4096"/>
+          </a:p>
+        </p:txBody>
       </p:sp>
       <p:sp>
         <p:nvSpPr>
@@ -6048,6 +6251,13 @@
             </a:outerShdw>
           </a:effectLst>
         </p:spPr>
+        <p:txBody>
+          <a:bodyPr/>
+          <a:lstStyle/>
+          <a:p>
+            <a:endParaRPr lang="LID4096"/>
+          </a:p>
+        </p:txBody>
       </p:sp>
       <p:sp>
         <p:nvSpPr>
@@ -6175,6 +6385,13 @@
             </a:outerShdw>
           </a:effectLst>
         </p:spPr>
+        <p:txBody>
+          <a:bodyPr/>
+          <a:lstStyle/>
+          <a:p>
+            <a:endParaRPr lang="LID4096"/>
+          </a:p>
+        </p:txBody>
       </p:sp>
       <p:sp>
         <p:nvSpPr>
@@ -6393,6 +6610,13 @@
             </a:outerShdw>
           </a:effectLst>
         </p:spPr>
+        <p:txBody>
+          <a:bodyPr/>
+          <a:lstStyle/>
+          <a:p>
+            <a:endParaRPr lang="LID4096"/>
+          </a:p>
+        </p:txBody>
       </p:sp>
       <p:sp>
         <p:nvSpPr>
@@ -6683,6 +6907,13 @@
             <a:prstDash val="solid"/>
           </a:ln>
         </p:spPr>
+        <p:txBody>
+          <a:bodyPr/>
+          <a:lstStyle/>
+          <a:p>
+            <a:endParaRPr lang="LID4096"/>
+          </a:p>
+        </p:txBody>
       </p:sp>
       <p:sp>
         <p:nvSpPr>
@@ -6825,6 +7056,13 @@
             <a:prstDash val="solid"/>
           </a:ln>
         </p:spPr>
+        <p:txBody>
+          <a:bodyPr/>
+          <a:lstStyle/>
+          <a:p>
+            <a:endParaRPr lang="LID4096"/>
+          </a:p>
+        </p:txBody>
       </p:sp>
       <p:sp>
         <p:nvSpPr>
@@ -6850,6 +7088,13 @@
             <a:prstDash val="solid"/>
           </a:ln>
         </p:spPr>
+        <p:txBody>
+          <a:bodyPr/>
+          <a:lstStyle/>
+          <a:p>
+            <a:endParaRPr lang="LID4096"/>
+          </a:p>
+        </p:txBody>
       </p:sp>
       <p:sp>
         <p:nvSpPr>
@@ -6953,6 +7198,13 @@
             <a:prstDash val="solid"/>
           </a:ln>
         </p:spPr>
+        <p:txBody>
+          <a:bodyPr/>
+          <a:lstStyle/>
+          <a:p>
+            <a:endParaRPr lang="LID4096"/>
+          </a:p>
+        </p:txBody>
       </p:sp>
       <p:sp>
         <p:nvSpPr>
@@ -6978,6 +7230,13 @@
             <a:prstDash val="solid"/>
           </a:ln>
         </p:spPr>
+        <p:txBody>
+          <a:bodyPr/>
+          <a:lstStyle/>
+          <a:p>
+            <a:endParaRPr lang="LID4096"/>
+          </a:p>
+        </p:txBody>
       </p:sp>
       <p:sp>
         <p:nvSpPr>
@@ -7081,6 +7340,13 @@
             <a:prstDash val="solid"/>
           </a:ln>
         </p:spPr>
+        <p:txBody>
+          <a:bodyPr/>
+          <a:lstStyle/>
+          <a:p>
+            <a:endParaRPr lang="LID4096"/>
+          </a:p>
+        </p:txBody>
       </p:sp>
       <p:sp>
         <p:nvSpPr>
@@ -7106,6 +7372,13 @@
             <a:prstDash val="solid"/>
           </a:ln>
         </p:spPr>
+        <p:txBody>
+          <a:bodyPr/>
+          <a:lstStyle/>
+          <a:p>
+            <a:endParaRPr lang="LID4096"/>
+          </a:p>
+        </p:txBody>
       </p:sp>
       <p:sp>
         <p:nvSpPr>
@@ -7209,6 +7482,13 @@
             <a:prstDash val="solid"/>
           </a:ln>
         </p:spPr>
+        <p:txBody>
+          <a:bodyPr/>
+          <a:lstStyle/>
+          <a:p>
+            <a:endParaRPr lang="LID4096"/>
+          </a:p>
+        </p:txBody>
       </p:sp>
       <p:sp>
         <p:nvSpPr>
@@ -7234,6 +7514,13 @@
             <a:prstDash val="solid"/>
           </a:ln>
         </p:spPr>
+        <p:txBody>
+          <a:bodyPr/>
+          <a:lstStyle/>
+          <a:p>
+            <a:endParaRPr lang="LID4096"/>
+          </a:p>
+        </p:txBody>
       </p:sp>
       <p:sp>
         <p:nvSpPr>
@@ -7337,6 +7624,13 @@
             <a:prstDash val="solid"/>
           </a:ln>
         </p:spPr>
+        <p:txBody>
+          <a:bodyPr/>
+          <a:lstStyle/>
+          <a:p>
+            <a:endParaRPr lang="LID4096"/>
+          </a:p>
+        </p:txBody>
       </p:sp>
       <p:sp>
         <p:nvSpPr>
@@ -7537,6 +7831,13 @@
             <a:prstDash val="solid"/>
           </a:ln>
         </p:spPr>
+        <p:txBody>
+          <a:bodyPr/>
+          <a:lstStyle/>
+          <a:p>
+            <a:endParaRPr lang="LID4096"/>
+          </a:p>
+        </p:txBody>
       </p:sp>
       <p:sp>
         <p:nvSpPr>
@@ -7702,6 +8003,13 @@
             </a:outerShdw>
           </a:effectLst>
         </p:spPr>
+        <p:txBody>
+          <a:bodyPr/>
+          <a:lstStyle/>
+          <a:p>
+            <a:endParaRPr lang="LID4096"/>
+          </a:p>
+        </p:txBody>
       </p:sp>
       <p:sp>
         <p:nvSpPr>
@@ -7727,6 +8035,13 @@
             <a:prstDash val="solid"/>
           </a:ln>
         </p:spPr>
+        <p:txBody>
+          <a:bodyPr/>
+          <a:lstStyle/>
+          <a:p>
+            <a:endParaRPr lang="LID4096"/>
+          </a:p>
+        </p:txBody>
       </p:sp>
       <p:sp>
         <p:nvSpPr>
@@ -7837,6 +8152,13 @@
             </a:outerShdw>
           </a:effectLst>
         </p:spPr>
+        <p:txBody>
+          <a:bodyPr/>
+          <a:lstStyle/>
+          <a:p>
+            <a:endParaRPr lang="LID4096"/>
+          </a:p>
+        </p:txBody>
       </p:sp>
       <p:sp>
         <p:nvSpPr>
@@ -7862,6 +8184,13 @@
             <a:prstDash val="solid"/>
           </a:ln>
         </p:spPr>
+        <p:txBody>
+          <a:bodyPr/>
+          <a:lstStyle/>
+          <a:p>
+            <a:endParaRPr lang="LID4096"/>
+          </a:p>
+        </p:txBody>
       </p:sp>
       <p:sp>
         <p:nvSpPr>
@@ -7972,6 +8301,13 @@
             </a:outerShdw>
           </a:effectLst>
         </p:spPr>
+        <p:txBody>
+          <a:bodyPr/>
+          <a:lstStyle/>
+          <a:p>
+            <a:endParaRPr lang="LID4096"/>
+          </a:p>
+        </p:txBody>
       </p:sp>
       <p:sp>
         <p:nvSpPr>
@@ -7997,6 +8333,13 @@
             <a:prstDash val="solid"/>
           </a:ln>
         </p:spPr>
+        <p:txBody>
+          <a:bodyPr/>
+          <a:lstStyle/>
+          <a:p>
+            <a:endParaRPr lang="LID4096"/>
+          </a:p>
+        </p:txBody>
       </p:sp>
       <p:sp>
         <p:nvSpPr>
@@ -8220,6 +8563,13 @@
             <a:prstDash val="solid"/>
           </a:ln>
         </p:spPr>
+        <p:txBody>
+          <a:bodyPr/>
+          <a:lstStyle/>
+          <a:p>
+            <a:endParaRPr lang="LID4096"/>
+          </a:p>
+        </p:txBody>
       </p:sp>
       <p:sp>
         <p:nvSpPr>
@@ -8362,6 +8712,13 @@
             <a:prstDash val="solid"/>
           </a:ln>
         </p:spPr>
+        <p:txBody>
+          <a:bodyPr/>
+          <a:lstStyle/>
+          <a:p>
+            <a:endParaRPr lang="LID4096"/>
+          </a:p>
+        </p:txBody>
       </p:sp>
       <p:sp>
         <p:nvSpPr>
@@ -8387,6 +8744,13 @@
             <a:prstDash val="solid"/>
           </a:ln>
         </p:spPr>
+        <p:txBody>
+          <a:bodyPr/>
+          <a:lstStyle/>
+          <a:p>
+            <a:endParaRPr lang="LID4096"/>
+          </a:p>
+        </p:txBody>
       </p:sp>
       <p:sp>
         <p:nvSpPr>
@@ -8490,6 +8854,13 @@
             <a:prstDash val="solid"/>
           </a:ln>
         </p:spPr>
+        <p:txBody>
+          <a:bodyPr/>
+          <a:lstStyle/>
+          <a:p>
+            <a:endParaRPr lang="LID4096"/>
+          </a:p>
+        </p:txBody>
       </p:sp>
       <p:sp>
         <p:nvSpPr>
@@ -8515,6 +8886,13 @@
             <a:prstDash val="solid"/>
           </a:ln>
         </p:spPr>
+        <p:txBody>
+          <a:bodyPr/>
+          <a:lstStyle/>
+          <a:p>
+            <a:endParaRPr lang="LID4096"/>
+          </a:p>
+        </p:txBody>
       </p:sp>
       <p:sp>
         <p:nvSpPr>
@@ -8618,6 +8996,13 @@
             <a:prstDash val="solid"/>
           </a:ln>
         </p:spPr>
+        <p:txBody>
+          <a:bodyPr/>
+          <a:lstStyle/>
+          <a:p>
+            <a:endParaRPr lang="LID4096"/>
+          </a:p>
+        </p:txBody>
       </p:sp>
       <p:sp>
         <p:nvSpPr>
@@ -8643,6 +9028,13 @@
             <a:prstDash val="solid"/>
           </a:ln>
         </p:spPr>
+        <p:txBody>
+          <a:bodyPr/>
+          <a:lstStyle/>
+          <a:p>
+            <a:endParaRPr lang="LID4096"/>
+          </a:p>
+        </p:txBody>
       </p:sp>
       <p:sp>
         <p:nvSpPr>
@@ -8746,6 +9138,13 @@
             <a:prstDash val="solid"/>
           </a:ln>
         </p:spPr>
+        <p:txBody>
+          <a:bodyPr/>
+          <a:lstStyle/>
+          <a:p>
+            <a:endParaRPr lang="LID4096"/>
+          </a:p>
+        </p:txBody>
       </p:sp>
       <p:sp>
         <p:nvSpPr>
@@ -8771,6 +9170,13 @@
             <a:prstDash val="solid"/>
           </a:ln>
         </p:spPr>
+        <p:txBody>
+          <a:bodyPr/>
+          <a:lstStyle/>
+          <a:p>
+            <a:endParaRPr lang="LID4096"/>
+          </a:p>
+        </p:txBody>
       </p:sp>
       <p:sp>
         <p:nvSpPr>
@@ -8874,6 +9280,13 @@
             <a:prstDash val="solid"/>
           </a:ln>
         </p:spPr>
+        <p:txBody>
+          <a:bodyPr/>
+          <a:lstStyle/>
+          <a:p>
+            <a:endParaRPr lang="LID4096"/>
+          </a:p>
+        </p:txBody>
       </p:sp>
       <p:sp>
         <p:nvSpPr>
@@ -8899,6 +9312,13 @@
             <a:prstDash val="solid"/>
           </a:ln>
         </p:spPr>
+        <p:txBody>
+          <a:bodyPr/>
+          <a:lstStyle/>
+          <a:p>
+            <a:endParaRPr lang="LID4096"/>
+          </a:p>
+        </p:txBody>
       </p:sp>
       <p:sp>
         <p:nvSpPr>
@@ -9120,7 +9540,7 @@
                 <a:ea typeface="Calibri" pitchFamily="34" charset="-122"/>
                 <a:cs typeface="Calibri" pitchFamily="34" charset="-120"/>
               </a:rPr>
-              <a:t>Mechanism check is only evidence: MCAR/MAR/NMAR cannot be proven from Phase I</a:t>
+              <a:t>Mechanism check is only evidence: MCAR/MAR/NMAR not proven in Phase I, but first assumptions tested.</a:t>
             </a:r>
             <a:endParaRPr lang="en-US" sz="900" dirty="0"/>
           </a:p>
@@ -9150,6 +9570,13 @@
             <a:prstDash val="solid"/>
           </a:ln>
         </p:spPr>
+        <p:txBody>
+          <a:bodyPr/>
+          <a:lstStyle/>
+          <a:p>
+            <a:endParaRPr lang="LID4096"/>
+          </a:p>
+        </p:txBody>
       </p:sp>
       <p:sp>
         <p:nvSpPr>
@@ -9310,6 +9737,13 @@
             <a:prstDash val="solid"/>
           </a:ln>
         </p:spPr>
+        <p:txBody>
+          <a:bodyPr/>
+          <a:lstStyle/>
+          <a:p>
+            <a:endParaRPr lang="LID4096"/>
+          </a:p>
+        </p:txBody>
       </p:sp>
       <p:sp>
         <p:nvSpPr>
@@ -9589,6 +10023,13 @@
             </a:outerShdw>
           </a:effectLst>
         </p:spPr>
+        <p:txBody>
+          <a:bodyPr/>
+          <a:lstStyle/>
+          <a:p>
+            <a:endParaRPr lang="LID4096"/>
+          </a:p>
+        </p:txBody>
       </p:sp>
       <p:sp>
         <p:nvSpPr>
@@ -9614,6 +10055,13 @@
             <a:prstDash val="solid"/>
           </a:ln>
         </p:spPr>
+        <p:txBody>
+          <a:bodyPr/>
+          <a:lstStyle/>
+          <a:p>
+            <a:endParaRPr lang="LID4096"/>
+          </a:p>
+        </p:txBody>
       </p:sp>
       <p:sp>
         <p:nvSpPr>
@@ -9724,6 +10172,13 @@
             </a:outerShdw>
           </a:effectLst>
         </p:spPr>
+        <p:txBody>
+          <a:bodyPr/>
+          <a:lstStyle/>
+          <a:p>
+            <a:endParaRPr lang="LID4096"/>
+          </a:p>
+        </p:txBody>
       </p:sp>
       <p:sp>
         <p:nvSpPr>
@@ -9749,6 +10204,13 @@
             <a:prstDash val="solid"/>
           </a:ln>
         </p:spPr>
+        <p:txBody>
+          <a:bodyPr/>
+          <a:lstStyle/>
+          <a:p>
+            <a:endParaRPr lang="LID4096"/>
+          </a:p>
+        </p:txBody>
       </p:sp>
       <p:sp>
         <p:nvSpPr>
@@ -9859,6 +10321,13 @@
             </a:outerShdw>
           </a:effectLst>
         </p:spPr>
+        <p:txBody>
+          <a:bodyPr/>
+          <a:lstStyle/>
+          <a:p>
+            <a:endParaRPr lang="LID4096"/>
+          </a:p>
+        </p:txBody>
       </p:sp>
       <p:sp>
         <p:nvSpPr>
@@ -9884,6 +10353,13 @@
             <a:prstDash val="solid"/>
           </a:ln>
         </p:spPr>
+        <p:txBody>
+          <a:bodyPr/>
+          <a:lstStyle/>
+          <a:p>
+            <a:endParaRPr lang="LID4096"/>
+          </a:p>
+        </p:txBody>
       </p:sp>
       <p:sp>
         <p:nvSpPr>
@@ -9994,6 +10470,13 @@
             </a:outerShdw>
           </a:effectLst>
         </p:spPr>
+        <p:txBody>
+          <a:bodyPr/>
+          <a:lstStyle/>
+          <a:p>
+            <a:endParaRPr lang="LID4096"/>
+          </a:p>
+        </p:txBody>
       </p:sp>
       <p:sp>
         <p:nvSpPr>
@@ -10019,6 +10502,13 @@
             <a:prstDash val="solid"/>
           </a:ln>
         </p:spPr>
+        <p:txBody>
+          <a:bodyPr/>
+          <a:lstStyle/>
+          <a:p>
+            <a:endParaRPr lang="LID4096"/>
+          </a:p>
+        </p:txBody>
       </p:sp>
       <p:sp>
         <p:nvSpPr>
@@ -10129,6 +10619,13 @@
             </a:outerShdw>
           </a:effectLst>
         </p:spPr>
+        <p:txBody>
+          <a:bodyPr/>
+          <a:lstStyle/>
+          <a:p>
+            <a:endParaRPr lang="LID4096"/>
+          </a:p>
+        </p:txBody>
       </p:sp>
       <p:sp>
         <p:nvSpPr>
@@ -10154,6 +10651,13 @@
             <a:prstDash val="solid"/>
           </a:ln>
         </p:spPr>
+        <p:txBody>
+          <a:bodyPr/>
+          <a:lstStyle/>
+          <a:p>
+            <a:endParaRPr lang="LID4096"/>
+          </a:p>
+        </p:txBody>
       </p:sp>
       <p:sp>
         <p:nvSpPr>
@@ -10431,6 +10935,13 @@
             <a:prstDash val="solid"/>
           </a:ln>
         </p:spPr>
+        <p:txBody>
+          <a:bodyPr/>
+          <a:lstStyle/>
+          <a:p>
+            <a:endParaRPr lang="LID4096"/>
+          </a:p>
+        </p:txBody>
       </p:sp>
       <p:pic>
         <p:nvPicPr>
@@ -10558,6 +11069,13 @@
             <a:prstDash val="solid"/>
           </a:ln>
         </p:spPr>
+        <p:txBody>
+          <a:bodyPr/>
+          <a:lstStyle/>
+          <a:p>
+            <a:endParaRPr lang="LID4096"/>
+          </a:p>
+        </p:txBody>
       </p:sp>
       <p:pic>
         <p:nvPicPr>
@@ -10655,7 +11173,7 @@
                 <a:ea typeface="Calibri" pitchFamily="34" charset="-122"/>
                 <a:cs typeface="Calibri" pitchFamily="34" charset="-120"/>
               </a:rPr>
-              <a:t>Two columns are 100% missing; medical_information is 85.18% missing. MCAR/MAR/NMAR cannot be proven, so strategy stays cautious.</a:t>
+              <a:t>Two columns are 100% missing; medical_information is 85.18% missing. MCAR/MAR/NMAR is tested, but strategy stays cautious for detailed analysis in phase 2 if necessary.</a:t>
             </a:r>
             <a:endParaRPr lang="en-US" sz="900" dirty="0"/>
           </a:p>
@@ -10685,6 +11203,13 @@
             <a:prstDash val="solid"/>
           </a:ln>
         </p:spPr>
+        <p:txBody>
+          <a:bodyPr/>
+          <a:lstStyle/>
+          <a:p>
+            <a:endParaRPr lang="LID4096"/>
+          </a:p>
+        </p:txBody>
       </p:sp>
       <p:pic>
         <p:nvPicPr>
@@ -10812,6 +11337,13 @@
             <a:prstDash val="solid"/>
           </a:ln>
         </p:spPr>
+        <p:txBody>
+          <a:bodyPr/>
+          <a:lstStyle/>
+          <a:p>
+            <a:endParaRPr lang="LID4096"/>
+          </a:p>
+        </p:txBody>
       </p:sp>
       <p:pic>
         <p:nvPicPr>
@@ -10939,6 +11471,13 @@
             <a:prstDash val="solid"/>
           </a:ln>
         </p:spPr>
+        <p:txBody>
+          <a:bodyPr/>
+          <a:lstStyle/>
+          <a:p>
+            <a:endParaRPr lang="LID4096"/>
+          </a:p>
+        </p:txBody>
       </p:sp>
       <p:pic>
         <p:nvPicPr>
@@ -11066,6 +11605,13 @@
             <a:prstDash val="solid"/>
           </a:ln>
         </p:spPr>
+        <p:txBody>
+          <a:bodyPr/>
+          <a:lstStyle/>
+          <a:p>
+            <a:endParaRPr lang="LID4096"/>
+          </a:p>
+        </p:txBody>
       </p:sp>
       <p:pic>
         <p:nvPicPr>

</xml_diff>